<commit_message>
General English namunasi: PPT ga emojilar qo'shildi
Doimiy emojilar (🎯 Bu darsda, 📝 Topshiriq, 💡 Strategiya, ⚠️ Tuzoq,
🎉 Xulosa) va darsga xos emojilar (muqova, maqsadlar, kalit so'zlar,
qoidalar) — lessons/dNN.js dagi emoji maydoni orqali.

Co-Authored-By: Claude Opus 5.5 <noreply@anthropic.com>
Claude-Session: https://claude.ai/code/session_013aXhZKNhzDeod3cL62AYW1
</commit_message>
<xml_diff>
--- a/general-english/namuna/Dars03_Present_Simple.pptx
+++ b/general-english/namuna/Dars03_Present_Simple.pptx
@@ -2284,6 +2284,305 @@
           </a:p>
         </p:txBody>
       </p:sp>
+      <p:sp>
+        <p:nvSpPr>
+          <p:cNvPr id="11" name="Shape 9"/>
+          <p:cNvSpPr/>
+          <p:nvPr/>
+        </p:nvSpPr>
+        <p:spPr>
+          <a:xfrm>
+            <a:off x="8001000" y="960120"/>
+            <a:ext cx="868680" cy="868680"/>
+          </a:xfrm>
+          <a:prstGeom prst="ellipse">
+            <a:avLst/>
+          </a:prstGeom>
+          <a:solidFill>
+            <a:srgbClr val="FFFFFF"/>
+          </a:solidFill>
+          <a:ln w="31750">
+            <a:solidFill>
+              <a:srgbClr val="F59E0B"/>
+            </a:solidFill>
+            <a:prstDash val="solid"/>
+          </a:ln>
+        </p:spPr>
+      </p:sp>
+      <p:sp>
+        <p:nvSpPr>
+          <p:cNvPr id="12" name="Text 10"/>
+          <p:cNvSpPr/>
+          <p:nvPr/>
+        </p:nvSpPr>
+        <p:spPr>
+          <a:xfrm>
+            <a:off x="8001000" y="960120"/>
+            <a:ext cx="868680" cy="868680"/>
+          </a:xfrm>
+          <a:prstGeom prst="rect">
+            <a:avLst/>
+          </a:prstGeom>
+          <a:noFill/>
+          <a:ln/>
+        </p:spPr>
+        <p:txBody>
+          <a:bodyPr wrap="square" lIns="0" tIns="0" rIns="0" bIns="0" rtlCol="0" anchor="ctr"/>
+          <a:lstStyle/>
+          <a:p>
+            <a:pPr algn="ctr" indent="0" marL="0">
+              <a:buNone/>
+            </a:pPr>
+            <a:r>
+              <a:rPr lang="en-US" sz="3000" dirty="0">
+                <a:solidFill>
+                  <a:srgbClr val="374151"/>
+                </a:solidFill>
+                <a:latin typeface="Segoe UI Emoji" pitchFamily="34" charset="0"/>
+                <a:ea typeface="Segoe UI Emoji" pitchFamily="34" charset="-122"/>
+                <a:cs typeface="Segoe UI Emoji" pitchFamily="34" charset="-120"/>
+              </a:rPr>
+              <a:t>⏰</a:t>
+            </a:r>
+            <a:endParaRPr lang="en-US" sz="3000" dirty="0"/>
+          </a:p>
+        </p:txBody>
+      </p:sp>
+      <p:sp>
+        <p:nvSpPr>
+          <p:cNvPr id="13" name="Text 11"/>
+          <p:cNvSpPr/>
+          <p:nvPr/>
+        </p:nvSpPr>
+        <p:spPr>
+          <a:xfrm>
+            <a:off x="548640" y="3154680"/>
+            <a:ext cx="5852160" cy="411480"/>
+          </a:xfrm>
+          <a:prstGeom prst="rect">
+            <a:avLst/>
+          </a:prstGeom>
+          <a:noFill/>
+          <a:ln/>
+        </p:spPr>
+        <p:txBody>
+          <a:bodyPr wrap="square" lIns="0" tIns="0" rIns="0" bIns="0" rtlCol="0" anchor="ctr"/>
+          <a:lstStyle/>
+          <a:p>
+            <a:pPr indent="0" marL="0">
+              <a:buNone/>
+            </a:pPr>
+            <a:r>
+              <a:rPr lang="en-US" sz="1800" spc="400" kern="0" dirty="0">
+                <a:solidFill>
+                  <a:srgbClr val="374151"/>
+                </a:solidFill>
+                <a:latin typeface="Segoe UI Emoji" pitchFamily="34" charset="0"/>
+                <a:ea typeface="Segoe UI Emoji" pitchFamily="34" charset="-122"/>
+                <a:cs typeface="Segoe UI Emoji" pitchFamily="34" charset="-120"/>
+              </a:rPr>
+              <a:t>☀️</a:t>
+            </a:r>
+            <a:pPr indent="0" marL="0">
+              <a:buNone/>
+            </a:pPr>
+            <a:r>
+              <a:rPr lang="en-US" sz="1800" spc="400" kern="0" dirty="0">
+                <a:solidFill>
+                  <a:srgbClr val="374151"/>
+                </a:solidFill>
+                <a:latin typeface="Calibri" pitchFamily="34" charset="0"/>
+                <a:ea typeface="Calibri" pitchFamily="34" charset="-122"/>
+                <a:cs typeface="Calibri" pitchFamily="34" charset="-120"/>
+              </a:rPr>
+              <a:t> </a:t>
+            </a:r>
+            <a:pPr indent="0" marL="0">
+              <a:buNone/>
+            </a:pPr>
+            <a:r>
+              <a:rPr lang="en-US" sz="1800" spc="400" kern="0" dirty="0">
+                <a:solidFill>
+                  <a:srgbClr val="374151"/>
+                </a:solidFill>
+                <a:latin typeface="Segoe UI Emoji" pitchFamily="34" charset="0"/>
+                <a:ea typeface="Segoe UI Emoji" pitchFamily="34" charset="-122"/>
+                <a:cs typeface="Segoe UI Emoji" pitchFamily="34" charset="-120"/>
+              </a:rPr>
+              <a:t>🪥</a:t>
+            </a:r>
+            <a:pPr indent="0" marL="0">
+              <a:buNone/>
+            </a:pPr>
+            <a:r>
+              <a:rPr lang="en-US" sz="1800" spc="400" kern="0" dirty="0">
+                <a:solidFill>
+                  <a:srgbClr val="374151"/>
+                </a:solidFill>
+                <a:latin typeface="Calibri" pitchFamily="34" charset="0"/>
+                <a:ea typeface="Calibri" pitchFamily="34" charset="-122"/>
+                <a:cs typeface="Calibri" pitchFamily="34" charset="-120"/>
+              </a:rPr>
+              <a:t> </a:t>
+            </a:r>
+            <a:pPr indent="0" marL="0">
+              <a:buNone/>
+            </a:pPr>
+            <a:r>
+              <a:rPr lang="en-US" sz="1800" spc="400" kern="0" dirty="0">
+                <a:solidFill>
+                  <a:srgbClr val="374151"/>
+                </a:solidFill>
+                <a:latin typeface="Segoe UI Emoji" pitchFamily="34" charset="0"/>
+                <a:ea typeface="Segoe UI Emoji" pitchFamily="34" charset="-122"/>
+                <a:cs typeface="Segoe UI Emoji" pitchFamily="34" charset="-120"/>
+              </a:rPr>
+              <a:t>🍳</a:t>
+            </a:r>
+            <a:pPr indent="0" marL="0">
+              <a:buNone/>
+            </a:pPr>
+            <a:r>
+              <a:rPr lang="en-US" sz="1800" spc="400" kern="0" dirty="0">
+                <a:solidFill>
+                  <a:srgbClr val="374151"/>
+                </a:solidFill>
+                <a:latin typeface="Calibri" pitchFamily="34" charset="0"/>
+                <a:ea typeface="Calibri" pitchFamily="34" charset="-122"/>
+                <a:cs typeface="Calibri" pitchFamily="34" charset="-120"/>
+              </a:rPr>
+              <a:t> </a:t>
+            </a:r>
+            <a:pPr indent="0" marL="0">
+              <a:buNone/>
+            </a:pPr>
+            <a:r>
+              <a:rPr lang="en-US" sz="1800" spc="400" kern="0" dirty="0">
+                <a:solidFill>
+                  <a:srgbClr val="374151"/>
+                </a:solidFill>
+                <a:latin typeface="Segoe UI Emoji" pitchFamily="34" charset="0"/>
+                <a:ea typeface="Segoe UI Emoji" pitchFamily="34" charset="-122"/>
+                <a:cs typeface="Segoe UI Emoji" pitchFamily="34" charset="-120"/>
+              </a:rPr>
+              <a:t>🚌</a:t>
+            </a:r>
+            <a:pPr indent="0" marL="0">
+              <a:buNone/>
+            </a:pPr>
+            <a:r>
+              <a:rPr lang="en-US" sz="1800" spc="400" kern="0" dirty="0">
+                <a:solidFill>
+                  <a:srgbClr val="374151"/>
+                </a:solidFill>
+                <a:latin typeface="Calibri" pitchFamily="34" charset="0"/>
+                <a:ea typeface="Calibri" pitchFamily="34" charset="-122"/>
+                <a:cs typeface="Calibri" pitchFamily="34" charset="-120"/>
+              </a:rPr>
+              <a:t> </a:t>
+            </a:r>
+            <a:pPr indent="0" marL="0">
+              <a:buNone/>
+            </a:pPr>
+            <a:r>
+              <a:rPr lang="en-US" sz="1800" spc="400" kern="0" dirty="0">
+                <a:solidFill>
+                  <a:srgbClr val="374151"/>
+                </a:solidFill>
+                <a:latin typeface="Segoe UI Emoji" pitchFamily="34" charset="0"/>
+                <a:ea typeface="Segoe UI Emoji" pitchFamily="34" charset="-122"/>
+                <a:cs typeface="Segoe UI Emoji" pitchFamily="34" charset="-120"/>
+              </a:rPr>
+              <a:t>🏫</a:t>
+            </a:r>
+            <a:pPr indent="0" marL="0">
+              <a:buNone/>
+            </a:pPr>
+            <a:r>
+              <a:rPr lang="en-US" sz="1800" spc="400" kern="0" dirty="0">
+                <a:solidFill>
+                  <a:srgbClr val="374151"/>
+                </a:solidFill>
+                <a:latin typeface="Calibri" pitchFamily="34" charset="0"/>
+                <a:ea typeface="Calibri" pitchFamily="34" charset="-122"/>
+                <a:cs typeface="Calibri" pitchFamily="34" charset="-120"/>
+              </a:rPr>
+              <a:t> </a:t>
+            </a:r>
+            <a:pPr indent="0" marL="0">
+              <a:buNone/>
+            </a:pPr>
+            <a:r>
+              <a:rPr lang="en-US" sz="1800" spc="400" kern="0" dirty="0">
+                <a:solidFill>
+                  <a:srgbClr val="374151"/>
+                </a:solidFill>
+                <a:latin typeface="Segoe UI Emoji" pitchFamily="34" charset="0"/>
+                <a:ea typeface="Segoe UI Emoji" pitchFamily="34" charset="-122"/>
+                <a:cs typeface="Segoe UI Emoji" pitchFamily="34" charset="-120"/>
+              </a:rPr>
+              <a:t>⚽</a:t>
+            </a:r>
+            <a:pPr indent="0" marL="0">
+              <a:buNone/>
+            </a:pPr>
+            <a:r>
+              <a:rPr lang="en-US" sz="1800" spc="400" kern="0" dirty="0">
+                <a:solidFill>
+                  <a:srgbClr val="374151"/>
+                </a:solidFill>
+                <a:latin typeface="Calibri" pitchFamily="34" charset="0"/>
+                <a:ea typeface="Calibri" pitchFamily="34" charset="-122"/>
+                <a:cs typeface="Calibri" pitchFamily="34" charset="-120"/>
+              </a:rPr>
+              <a:t> </a:t>
+            </a:r>
+            <a:pPr indent="0" marL="0">
+              <a:buNone/>
+            </a:pPr>
+            <a:r>
+              <a:rPr lang="en-US" sz="1800" spc="400" kern="0" dirty="0">
+                <a:solidFill>
+                  <a:srgbClr val="374151"/>
+                </a:solidFill>
+                <a:latin typeface="Segoe UI Emoji" pitchFamily="34" charset="0"/>
+                <a:ea typeface="Segoe UI Emoji" pitchFamily="34" charset="-122"/>
+                <a:cs typeface="Segoe UI Emoji" pitchFamily="34" charset="-120"/>
+              </a:rPr>
+              <a:t>📺</a:t>
+            </a:r>
+            <a:pPr indent="0" marL="0">
+              <a:buNone/>
+            </a:pPr>
+            <a:r>
+              <a:rPr lang="en-US" sz="1800" spc="400" kern="0" dirty="0">
+                <a:solidFill>
+                  <a:srgbClr val="374151"/>
+                </a:solidFill>
+                <a:latin typeface="Calibri" pitchFamily="34" charset="0"/>
+                <a:ea typeface="Calibri" pitchFamily="34" charset="-122"/>
+                <a:cs typeface="Calibri" pitchFamily="34" charset="-120"/>
+              </a:rPr>
+              <a:t> </a:t>
+            </a:r>
+            <a:pPr indent="0" marL="0">
+              <a:buNone/>
+            </a:pPr>
+            <a:r>
+              <a:rPr lang="en-US" sz="1800" spc="400" kern="0" dirty="0">
+                <a:solidFill>
+                  <a:srgbClr val="374151"/>
+                </a:solidFill>
+                <a:latin typeface="Segoe UI Emoji" pitchFamily="34" charset="0"/>
+                <a:ea typeface="Segoe UI Emoji" pitchFamily="34" charset="-122"/>
+                <a:cs typeface="Segoe UI Emoji" pitchFamily="34" charset="-120"/>
+              </a:rPr>
+              <a:t>😴</a:t>
+            </a:r>
+            <a:endParaRPr lang="en-US" sz="1800" dirty="0"/>
+          </a:p>
+        </p:txBody>
+      </p:sp>
     </p:spTree>
   </p:cSld>
   <p:clrMapOvr>
@@ -2338,11 +2637,25 @@
                 <a:solidFill>
                   <a:srgbClr val="1B1F3B"/>
                 </a:solidFill>
+                <a:latin typeface="Segoe UI Emoji" pitchFamily="34" charset="0"/>
+                <a:ea typeface="Segoe UI Emoji" pitchFamily="34" charset="-122"/>
+                <a:cs typeface="Segoe UI Emoji" pitchFamily="34" charset="-120"/>
+              </a:rPr>
+              <a:t>💪</a:t>
+            </a:r>
+            <a:pPr indent="0" marL="0">
+              <a:buNone/>
+            </a:pPr>
+            <a:r>
+              <a:rPr lang="en-US" sz="2800" b="1" dirty="0">
+                <a:solidFill>
+                  <a:srgbClr val="1B1F3B"/>
+                </a:solidFill>
                 <a:latin typeface="Cambria" pitchFamily="34" charset="0"/>
                 <a:ea typeface="Cambria" pitchFamily="34" charset="-122"/>
                 <a:cs typeface="Cambria" pitchFamily="34" charset="-120"/>
               </a:rPr>
-              <a:t>O'zingiz sinab ko'ring</a:t>
+              <a:t> O'zingiz sinab ko'ring</a:t>
             </a:r>
             <a:endParaRPr lang="en-US" sz="2800" dirty="0"/>
           </a:p>
@@ -3059,7 +3372,21 @@
                 <a:ea typeface="Calibri" pitchFamily="34" charset="-122"/>
                 <a:cs typeface="Calibri" pitchFamily="34" charset="-120"/>
               </a:rPr>
-              <a:t>Videoni to'xtating va yeching</a:t>
+              <a:t>Videoni to'xtating va yeching </a:t>
+            </a:r>
+            <a:pPr algn="ctr" indent="0" marL="0">
+              <a:buNone/>
+            </a:pPr>
+            <a:r>
+              <a:rPr lang="en-US" sz="1400" b="1" dirty="0">
+                <a:solidFill>
+                  <a:srgbClr val="FFFFFF"/>
+                </a:solidFill>
+                <a:latin typeface="Segoe UI Emoji" pitchFamily="34" charset="0"/>
+                <a:ea typeface="Segoe UI Emoji" pitchFamily="34" charset="-122"/>
+                <a:cs typeface="Segoe UI Emoji" pitchFamily="34" charset="-120"/>
+              </a:rPr>
+              <a:t>✍️</a:t>
             </a:r>
             <a:endParaRPr lang="en-US" sz="1400" dirty="0"/>
           </a:p>
@@ -3206,11 +3533,25 @@
                 <a:solidFill>
                   <a:srgbClr val="FFFFFF"/>
                 </a:solidFill>
+                <a:latin typeface="Segoe UI Emoji" pitchFamily="34" charset="0"/>
+                <a:ea typeface="Segoe UI Emoji" pitchFamily="34" charset="-122"/>
+                <a:cs typeface="Segoe UI Emoji" pitchFamily="34" charset="-120"/>
+              </a:rPr>
+              <a:t>🎉</a:t>
+            </a:r>
+            <a:pPr indent="0" marL="0">
+              <a:buNone/>
+            </a:pPr>
+            <a:r>
+              <a:rPr lang="en-US" sz="2800" b="1" dirty="0">
+                <a:solidFill>
+                  <a:srgbClr val="FFFFFF"/>
+                </a:solidFill>
                 <a:latin typeface="Cambria" pitchFamily="34" charset="0"/>
                 <a:ea typeface="Cambria" pitchFamily="34" charset="-122"/>
                 <a:cs typeface="Cambria" pitchFamily="34" charset="-120"/>
               </a:rPr>
-              <a:t>Xulosa</a:t>
+              <a:t> Xulosa</a:t>
             </a:r>
             <a:endParaRPr lang="en-US" sz="2800" dirty="0"/>
           </a:p>
@@ -3237,6 +3578,20 @@
           <a:bodyPr wrap="square" lIns="0" tIns="0" rIns="0" bIns="0" rtlCol="0" anchor="t"/>
           <a:lstStyle/>
           <a:p>
+            <a:pPr indent="0" marL="0">
+              <a:buNone/>
+            </a:pPr>
+            <a:r>
+              <a:rPr lang="en-US" sz="900" b="1" spc="200" kern="0" dirty="0">
+                <a:solidFill>
+                  <a:srgbClr val="F59E0B"/>
+                </a:solidFill>
+                <a:latin typeface="Segoe UI Emoji" pitchFamily="34" charset="0"/>
+                <a:ea typeface="Segoe UI Emoji" pitchFamily="34" charset="-122"/>
+                <a:cs typeface="Segoe UI Emoji" pitchFamily="34" charset="-120"/>
+              </a:rPr>
+              <a:t>🔑</a:t>
+            </a:r>
             <a:pPr indent="0" marL="0">
               <a:buNone/>
             </a:pPr>
@@ -3249,7 +3604,7 @@
                 <a:ea typeface="Calibri" pitchFamily="34" charset="-122"/>
                 <a:cs typeface="Calibri" pitchFamily="34" charset="-120"/>
               </a:rPr>
-              <a:t>JAVOBLAR</a:t>
+              <a:t> JAVOBLAR</a:t>
             </a:r>
             <a:endParaRPr lang="en-US" sz="900" dirty="0"/>
           </a:p>
@@ -3880,6 +4235,20 @@
               <a:buNone/>
             </a:pPr>
             <a:r>
+              <a:rPr lang="en-US" sz="1100" dirty="0">
+                <a:solidFill>
+                  <a:srgbClr val="F59E0B"/>
+                </a:solidFill>
+                <a:latin typeface="Segoe UI Emoji" pitchFamily="34" charset="0"/>
+                <a:ea typeface="Segoe UI Emoji" pitchFamily="34" charset="-122"/>
+                <a:cs typeface="Segoe UI Emoji" pitchFamily="34" charset="-120"/>
+              </a:rPr>
+              <a:t>🚀</a:t>
+            </a:r>
+            <a:pPr indent="0" marL="0">
+              <a:buNone/>
+            </a:pPr>
+            <a:r>
               <a:rPr lang="en-US" sz="1100" b="1" dirty="0">
                 <a:solidFill>
                   <a:srgbClr val="F59E0B"/>
@@ -3888,7 +4257,7 @@
                 <a:ea typeface="Calibri" pitchFamily="34" charset="-122"/>
                 <a:cs typeface="Calibri" pitchFamily="34" charset="-120"/>
               </a:rPr>
-              <a:t>Keyingi:  </a:t>
+              <a:t> Keyingi:  </a:t>
             </a:r>
             <a:pPr indent="0" marL="0">
               <a:buNone/>
@@ -3962,11 +4331,25 @@
                 <a:solidFill>
                   <a:srgbClr val="1B1F3B"/>
                 </a:solidFill>
+                <a:latin typeface="Segoe UI Emoji" pitchFamily="34" charset="0"/>
+                <a:ea typeface="Segoe UI Emoji" pitchFamily="34" charset="-122"/>
+                <a:cs typeface="Segoe UI Emoji" pitchFamily="34" charset="-120"/>
+              </a:rPr>
+              <a:t>🎯</a:t>
+            </a:r>
+            <a:pPr indent="0" marL="0">
+              <a:buNone/>
+            </a:pPr>
+            <a:r>
+              <a:rPr lang="en-US" sz="2800" b="1" dirty="0">
+                <a:solidFill>
+                  <a:srgbClr val="1B1F3B"/>
+                </a:solidFill>
                 <a:latin typeface="Cambria" pitchFamily="34" charset="0"/>
                 <a:ea typeface="Cambria" pitchFamily="34" charset="-122"/>
                 <a:cs typeface="Cambria" pitchFamily="34" charset="-120"/>
               </a:rPr>
-              <a:t>Bu darsda</a:t>
+              <a:t> Bu darsda</a:t>
             </a:r>
             <a:endParaRPr lang="en-US" sz="2800" dirty="0"/>
           </a:p>
@@ -4071,6 +4454,45 @@
         </p:nvSpPr>
         <p:spPr>
           <a:xfrm>
+            <a:off x="2240280" y="1463040"/>
+            <a:ext cx="685800" cy="685800"/>
+          </a:xfrm>
+          <a:prstGeom prst="rect">
+            <a:avLst/>
+          </a:prstGeom>
+          <a:noFill/>
+          <a:ln/>
+        </p:spPr>
+        <p:txBody>
+          <a:bodyPr wrap="square" lIns="0" tIns="0" rIns="0" bIns="0" rtlCol="0" anchor="ctr"/>
+          <a:lstStyle/>
+          <a:p>
+            <a:pPr algn="ctr" indent="0" marL="0">
+              <a:buNone/>
+            </a:pPr>
+            <a:r>
+              <a:rPr lang="en-US" sz="3200" dirty="0">
+                <a:solidFill>
+                  <a:srgbClr val="374151"/>
+                </a:solidFill>
+                <a:latin typeface="Segoe UI Emoji" pitchFamily="34" charset="0"/>
+                <a:ea typeface="Segoe UI Emoji" pitchFamily="34" charset="-122"/>
+                <a:cs typeface="Segoe UI Emoji" pitchFamily="34" charset="-120"/>
+              </a:rPr>
+              <a:t>✍️</a:t>
+            </a:r>
+            <a:endParaRPr lang="en-US" sz="3200" dirty="0"/>
+          </a:p>
+        </p:txBody>
+      </p:sp>
+      <p:sp>
+        <p:nvSpPr>
+          <p:cNvPr id="7" name="Text 5"/>
+          <p:cNvSpPr/>
+          <p:nvPr/>
+        </p:nvSpPr>
+        <p:spPr>
+          <a:xfrm>
             <a:off x="731520" y="2377440"/>
             <a:ext cx="2103120" cy="685800"/>
           </a:xfrm>
@@ -4104,7 +4526,7 @@
       </p:sp>
       <p:sp>
         <p:nvSpPr>
-          <p:cNvPr id="7" name="Text 5"/>
+          <p:cNvPr id="8" name="Text 6"/>
           <p:cNvSpPr/>
           <p:nvPr/>
         </p:nvSpPr>
@@ -4143,7 +4565,7 @@
       </p:sp>
       <p:sp>
         <p:nvSpPr>
-          <p:cNvPr id="8" name="Shape 6"/>
+          <p:cNvPr id="9" name="Shape 7"/>
           <p:cNvSpPr/>
           <p:nvPr/>
         </p:nvSpPr>
@@ -4170,7 +4592,7 @@
       </p:sp>
       <p:sp>
         <p:nvSpPr>
-          <p:cNvPr id="9" name="Shape 7"/>
+          <p:cNvPr id="10" name="Shape 8"/>
           <p:cNvSpPr/>
           <p:nvPr/>
         </p:nvSpPr>
@@ -4195,7 +4617,7 @@
       </p:sp>
       <p:sp>
         <p:nvSpPr>
-          <p:cNvPr id="10" name="Text 8"/>
+          <p:cNvPr id="11" name="Text 9"/>
           <p:cNvSpPr/>
           <p:nvPr/>
         </p:nvSpPr>
@@ -4234,7 +4656,46 @@
       </p:sp>
       <p:sp>
         <p:nvSpPr>
-          <p:cNvPr id="11" name="Text 9"/>
+          <p:cNvPr id="12" name="Text 10"/>
+          <p:cNvSpPr/>
+          <p:nvPr/>
+        </p:nvSpPr>
+        <p:spPr>
+          <a:xfrm>
+            <a:off x="5052060" y="1463040"/>
+            <a:ext cx="685800" cy="685800"/>
+          </a:xfrm>
+          <a:prstGeom prst="rect">
+            <a:avLst/>
+          </a:prstGeom>
+          <a:noFill/>
+          <a:ln/>
+        </p:spPr>
+        <p:txBody>
+          <a:bodyPr wrap="square" lIns="0" tIns="0" rIns="0" bIns="0" rtlCol="0" anchor="ctr"/>
+          <a:lstStyle/>
+          <a:p>
+            <a:pPr algn="ctr" indent="0" marL="0">
+              <a:buNone/>
+            </a:pPr>
+            <a:r>
+              <a:rPr lang="en-US" sz="3200" dirty="0">
+                <a:solidFill>
+                  <a:srgbClr val="374151"/>
+                </a:solidFill>
+                <a:latin typeface="Segoe UI Emoji" pitchFamily="34" charset="0"/>
+                <a:ea typeface="Segoe UI Emoji" pitchFamily="34" charset="-122"/>
+                <a:cs typeface="Segoe UI Emoji" pitchFamily="34" charset="-120"/>
+              </a:rPr>
+              <a:t>🔤</a:t>
+            </a:r>
+            <a:endParaRPr lang="en-US" sz="3200" dirty="0"/>
+          </a:p>
+        </p:txBody>
+      </p:sp>
+      <p:sp>
+        <p:nvSpPr>
+          <p:cNvPr id="13" name="Text 11"/>
           <p:cNvSpPr/>
           <p:nvPr/>
         </p:nvSpPr>
@@ -4273,7 +4734,7 @@
       </p:sp>
       <p:sp>
         <p:nvSpPr>
-          <p:cNvPr id="12" name="Text 10"/>
+          <p:cNvPr id="14" name="Text 12"/>
           <p:cNvSpPr/>
           <p:nvPr/>
         </p:nvSpPr>
@@ -4312,7 +4773,7 @@
       </p:sp>
       <p:sp>
         <p:nvSpPr>
-          <p:cNvPr id="13" name="Shape 11"/>
+          <p:cNvPr id="15" name="Shape 13"/>
           <p:cNvSpPr/>
           <p:nvPr/>
         </p:nvSpPr>
@@ -4339,7 +4800,7 @@
       </p:sp>
       <p:sp>
         <p:nvSpPr>
-          <p:cNvPr id="14" name="Shape 12"/>
+          <p:cNvPr id="16" name="Shape 14"/>
           <p:cNvSpPr/>
           <p:nvPr/>
         </p:nvSpPr>
@@ -4364,7 +4825,7 @@
       </p:sp>
       <p:sp>
         <p:nvSpPr>
-          <p:cNvPr id="15" name="Text 13"/>
+          <p:cNvPr id="17" name="Text 15"/>
           <p:cNvSpPr/>
           <p:nvPr/>
         </p:nvSpPr>
@@ -4403,7 +4864,46 @@
       </p:sp>
       <p:sp>
         <p:nvSpPr>
-          <p:cNvPr id="16" name="Text 14"/>
+          <p:cNvPr id="18" name="Text 16"/>
+          <p:cNvSpPr/>
+          <p:nvPr/>
+        </p:nvSpPr>
+        <p:spPr>
+          <a:xfrm>
+            <a:off x="7863840" y="1463040"/>
+            <a:ext cx="685800" cy="685800"/>
+          </a:xfrm>
+          <a:prstGeom prst="rect">
+            <a:avLst/>
+          </a:prstGeom>
+          <a:noFill/>
+          <a:ln/>
+        </p:spPr>
+        <p:txBody>
+          <a:bodyPr wrap="square" lIns="0" tIns="0" rIns="0" bIns="0" rtlCol="0" anchor="ctr"/>
+          <a:lstStyle/>
+          <a:p>
+            <a:pPr algn="ctr" indent="0" marL="0">
+              <a:buNone/>
+            </a:pPr>
+            <a:r>
+              <a:rPr lang="en-US" sz="3200" dirty="0">
+                <a:solidFill>
+                  <a:srgbClr val="374151"/>
+                </a:solidFill>
+                <a:latin typeface="Segoe UI Emoji" pitchFamily="34" charset="0"/>
+                <a:ea typeface="Segoe UI Emoji" pitchFamily="34" charset="-122"/>
+                <a:cs typeface="Segoe UI Emoji" pitchFamily="34" charset="-120"/>
+              </a:rPr>
+              <a:t>📅</a:t>
+            </a:r>
+            <a:endParaRPr lang="en-US" sz="3200" dirty="0"/>
+          </a:p>
+        </p:txBody>
+      </p:sp>
+      <p:sp>
+        <p:nvSpPr>
+          <p:cNvPr id="19" name="Text 17"/>
           <p:cNvSpPr/>
           <p:nvPr/>
         </p:nvSpPr>
@@ -4442,7 +4942,7 @@
       </p:sp>
       <p:sp>
         <p:nvSpPr>
-          <p:cNvPr id="17" name="Text 15"/>
+          <p:cNvPr id="20" name="Text 18"/>
           <p:cNvSpPr/>
           <p:nvPr/>
         </p:nvSpPr>
@@ -4581,11 +5081,25 @@
                 <a:solidFill>
                   <a:srgbClr val="1B1F3B"/>
                 </a:solidFill>
+                <a:latin typeface="Segoe UI Emoji" pitchFamily="34" charset="0"/>
+                <a:ea typeface="Segoe UI Emoji" pitchFamily="34" charset="-122"/>
+                <a:cs typeface="Segoe UI Emoji" pitchFamily="34" charset="-120"/>
+              </a:rPr>
+              <a:t>📚</a:t>
+            </a:r>
+            <a:pPr indent="0" marL="0">
+              <a:buNone/>
+            </a:pPr>
+            <a:r>
+              <a:rPr lang="en-US" sz="2800" b="1" dirty="0">
+                <a:solidFill>
+                  <a:srgbClr val="1B1F3B"/>
+                </a:solidFill>
                 <a:latin typeface="Cambria" pitchFamily="34" charset="0"/>
                 <a:ea typeface="Cambria" pitchFamily="34" charset="-122"/>
                 <a:cs typeface="Cambria" pitchFamily="34" charset="-120"/>
               </a:rPr>
-              <a:t>Inglizcha kalit so'zlar</a:t>
+              <a:t> Inglizcha kalit so'zlar</a:t>
             </a:r>
             <a:endParaRPr lang="en-US" sz="2800" dirty="0"/>
           </a:p>
@@ -4647,11 +5161,25 @@
                 <a:solidFill>
                   <a:srgbClr val="4F46E5"/>
                 </a:solidFill>
+                <a:latin typeface="Segoe UI Emoji" pitchFamily="34" charset="0"/>
+                <a:ea typeface="Segoe UI Emoji" pitchFamily="34" charset="-122"/>
+                <a:cs typeface="Segoe UI Emoji" pitchFamily="34" charset="-120"/>
+              </a:rPr>
+              <a:t>🔁</a:t>
+            </a:r>
+            <a:pPr indent="0" marL="0">
+              <a:buNone/>
+            </a:pPr>
+            <a:r>
+              <a:rPr lang="en-US" sz="1300" b="1" dirty="0">
+                <a:solidFill>
+                  <a:srgbClr val="4F46E5"/>
+                </a:solidFill>
                 <a:latin typeface="Calibri" pitchFamily="34" charset="0"/>
                 <a:ea typeface="Calibri" pitchFamily="34" charset="-122"/>
                 <a:cs typeface="Calibri" pitchFamily="34" charset="-120"/>
               </a:rPr>
-              <a:t>always</a:t>
+              <a:t> always</a:t>
             </a:r>
             <a:endParaRPr lang="en-US" sz="1300" dirty="0"/>
           </a:p>
@@ -4791,11 +5319,25 @@
                 <a:solidFill>
                   <a:srgbClr val="4F46E5"/>
                 </a:solidFill>
+                <a:latin typeface="Segoe UI Emoji" pitchFamily="34" charset="0"/>
+                <a:ea typeface="Segoe UI Emoji" pitchFamily="34" charset="-122"/>
+                <a:cs typeface="Segoe UI Emoji" pitchFamily="34" charset="-120"/>
+              </a:rPr>
+              <a:t>🙂</a:t>
+            </a:r>
+            <a:pPr indent="0" marL="0">
+              <a:buNone/>
+            </a:pPr>
+            <a:r>
+              <a:rPr lang="en-US" sz="1300" b="1" dirty="0">
+                <a:solidFill>
+                  <a:srgbClr val="4F46E5"/>
+                </a:solidFill>
                 <a:latin typeface="Calibri" pitchFamily="34" charset="0"/>
                 <a:ea typeface="Calibri" pitchFamily="34" charset="-122"/>
                 <a:cs typeface="Calibri" pitchFamily="34" charset="-120"/>
               </a:rPr>
-              <a:t>usually</a:t>
+              <a:t> usually</a:t>
             </a:r>
             <a:endParaRPr lang="en-US" sz="1300" dirty="0"/>
           </a:p>
@@ -4935,11 +5477,25 @@
                 <a:solidFill>
                   <a:srgbClr val="4F46E5"/>
                 </a:solidFill>
+                <a:latin typeface="Segoe UI Emoji" pitchFamily="34" charset="0"/>
+                <a:ea typeface="Segoe UI Emoji" pitchFamily="34" charset="-122"/>
+                <a:cs typeface="Segoe UI Emoji" pitchFamily="34" charset="-120"/>
+              </a:rPr>
+              <a:t>👍</a:t>
+            </a:r>
+            <a:pPr indent="0" marL="0">
+              <a:buNone/>
+            </a:pPr>
+            <a:r>
+              <a:rPr lang="en-US" sz="1300" b="1" dirty="0">
+                <a:solidFill>
+                  <a:srgbClr val="4F46E5"/>
+                </a:solidFill>
                 <a:latin typeface="Calibri" pitchFamily="34" charset="0"/>
                 <a:ea typeface="Calibri" pitchFamily="34" charset="-122"/>
                 <a:cs typeface="Calibri" pitchFamily="34" charset="-120"/>
               </a:rPr>
-              <a:t>often</a:t>
+              <a:t> often</a:t>
             </a:r>
             <a:endParaRPr lang="en-US" sz="1300" dirty="0"/>
           </a:p>
@@ -5079,11 +5635,25 @@
                 <a:solidFill>
                   <a:srgbClr val="4F46E5"/>
                 </a:solidFill>
+                <a:latin typeface="Segoe UI Emoji" pitchFamily="34" charset="0"/>
+                <a:ea typeface="Segoe UI Emoji" pitchFamily="34" charset="-122"/>
+                <a:cs typeface="Segoe UI Emoji" pitchFamily="34" charset="-120"/>
+              </a:rPr>
+              <a:t>🤷</a:t>
+            </a:r>
+            <a:pPr indent="0" marL="0">
+              <a:buNone/>
+            </a:pPr>
+            <a:r>
+              <a:rPr lang="en-US" sz="1300" b="1" dirty="0">
+                <a:solidFill>
+                  <a:srgbClr val="4F46E5"/>
+                </a:solidFill>
                 <a:latin typeface="Calibri" pitchFamily="34" charset="0"/>
                 <a:ea typeface="Calibri" pitchFamily="34" charset="-122"/>
                 <a:cs typeface="Calibri" pitchFamily="34" charset="-120"/>
               </a:rPr>
-              <a:t>sometimes</a:t>
+              <a:t> sometimes</a:t>
             </a:r>
             <a:endParaRPr lang="en-US" sz="1300" dirty="0"/>
           </a:p>
@@ -5223,11 +5793,25 @@
                 <a:solidFill>
                   <a:srgbClr val="4F46E5"/>
                 </a:solidFill>
+                <a:latin typeface="Segoe UI Emoji" pitchFamily="34" charset="0"/>
+                <a:ea typeface="Segoe UI Emoji" pitchFamily="34" charset="-122"/>
+                <a:cs typeface="Segoe UI Emoji" pitchFamily="34" charset="-120"/>
+              </a:rPr>
+              <a:t>🚫</a:t>
+            </a:r>
+            <a:pPr indent="0" marL="0">
+              <a:buNone/>
+            </a:pPr>
+            <a:r>
+              <a:rPr lang="en-US" sz="1300" b="1" dirty="0">
+                <a:solidFill>
+                  <a:srgbClr val="4F46E5"/>
+                </a:solidFill>
                 <a:latin typeface="Calibri" pitchFamily="34" charset="0"/>
                 <a:ea typeface="Calibri" pitchFamily="34" charset="-122"/>
                 <a:cs typeface="Calibri" pitchFamily="34" charset="-120"/>
               </a:rPr>
-              <a:t>never</a:t>
+              <a:t> never</a:t>
             </a:r>
             <a:endParaRPr lang="en-US" sz="1300" dirty="0"/>
           </a:p>
@@ -5367,11 +5951,25 @@
                 <a:solidFill>
                   <a:srgbClr val="4F46E5"/>
                 </a:solidFill>
+                <a:latin typeface="Segoe UI Emoji" pitchFamily="34" charset="0"/>
+                <a:ea typeface="Segoe UI Emoji" pitchFamily="34" charset="-122"/>
+                <a:cs typeface="Segoe UI Emoji" pitchFamily="34" charset="-120"/>
+              </a:rPr>
+              <a:t>📅</a:t>
+            </a:r>
+            <a:pPr indent="0" marL="0">
+              <a:buNone/>
+            </a:pPr>
+            <a:r>
+              <a:rPr lang="en-US" sz="1300" b="1" dirty="0">
+                <a:solidFill>
+                  <a:srgbClr val="4F46E5"/>
+                </a:solidFill>
                 <a:latin typeface="Calibri" pitchFamily="34" charset="0"/>
                 <a:ea typeface="Calibri" pitchFamily="34" charset="-122"/>
                 <a:cs typeface="Calibri" pitchFamily="34" charset="-120"/>
               </a:rPr>
-              <a:t>every day</a:t>
+              <a:t> every day</a:t>
             </a:r>
             <a:endParaRPr lang="en-US" sz="1300" dirty="0"/>
           </a:p>
@@ -5511,11 +6109,25 @@
                 <a:solidFill>
                   <a:srgbClr val="4F46E5"/>
                 </a:solidFill>
+                <a:latin typeface="Segoe UI Emoji" pitchFamily="34" charset="0"/>
+                <a:ea typeface="Segoe UI Emoji" pitchFamily="34" charset="-122"/>
+                <a:cs typeface="Segoe UI Emoji" pitchFamily="34" charset="-120"/>
+              </a:rPr>
+              <a:t>❓</a:t>
+            </a:r>
+            <a:pPr indent="0" marL="0">
+              <a:buNone/>
+            </a:pPr>
+            <a:r>
+              <a:rPr lang="en-US" sz="1300" b="1" dirty="0">
+                <a:solidFill>
+                  <a:srgbClr val="4F46E5"/>
+                </a:solidFill>
                 <a:latin typeface="Calibri" pitchFamily="34" charset="0"/>
                 <a:ea typeface="Calibri" pitchFamily="34" charset="-122"/>
                 <a:cs typeface="Calibri" pitchFamily="34" charset="-120"/>
               </a:rPr>
-              <a:t>does / doesn't</a:t>
+              <a:t> does / doesn't</a:t>
             </a:r>
             <a:endParaRPr lang="en-US" sz="1300" dirty="0"/>
           </a:p>
@@ -5655,11 +6267,25 @@
                 <a:solidFill>
                   <a:srgbClr val="4F46E5"/>
                 </a:solidFill>
+                <a:latin typeface="Segoe UI Emoji" pitchFamily="34" charset="0"/>
+                <a:ea typeface="Segoe UI Emoji" pitchFamily="34" charset="-122"/>
+                <a:cs typeface="Segoe UI Emoji" pitchFamily="34" charset="-120"/>
+              </a:rPr>
+              <a:t>⏰</a:t>
+            </a:r>
+            <a:pPr indent="0" marL="0">
+              <a:buNone/>
+            </a:pPr>
+            <a:r>
+              <a:rPr lang="en-US" sz="1300" b="1" dirty="0">
+                <a:solidFill>
+                  <a:srgbClr val="4F46E5"/>
+                </a:solidFill>
                 <a:latin typeface="Calibri" pitchFamily="34" charset="0"/>
                 <a:ea typeface="Calibri" pitchFamily="34" charset="-122"/>
                 <a:cs typeface="Calibri" pitchFamily="34" charset="-120"/>
               </a:rPr>
-              <a:t>daily routine</a:t>
+              <a:t> daily routine</a:t>
             </a:r>
             <a:endParaRPr lang="en-US" sz="1300" dirty="0"/>
           </a:p>
@@ -5845,11 +6471,25 @@
                 <a:solidFill>
                   <a:srgbClr val="1B1F3B"/>
                 </a:solidFill>
+                <a:latin typeface="Segoe UI Emoji" pitchFamily="34" charset="0"/>
+                <a:ea typeface="Segoe UI Emoji" pitchFamily="34" charset="-122"/>
+                <a:cs typeface="Segoe UI Emoji" pitchFamily="34" charset="-120"/>
+              </a:rPr>
+              <a:t>📌</a:t>
+            </a:r>
+            <a:pPr indent="0" marL="0">
+              <a:buNone/>
+            </a:pPr>
+            <a:r>
+              <a:rPr lang="en-US" sz="2800" b="1" dirty="0">
+                <a:solidFill>
+                  <a:srgbClr val="1B1F3B"/>
+                </a:solidFill>
                 <a:latin typeface="Cambria" pitchFamily="34" charset="0"/>
                 <a:ea typeface="Cambria" pitchFamily="34" charset="-122"/>
                 <a:cs typeface="Cambria" pitchFamily="34" charset="-120"/>
               </a:rPr>
-              <a:t>Present Simple: 4 qoida</a:t>
+              <a:t> Present Simple: 4 qoida</a:t>
             </a:r>
             <a:endParaRPr lang="en-US" sz="2800" dirty="0"/>
           </a:p>
@@ -5904,9 +6544,9 @@
             <a:avLst/>
           </a:prstGeom>
           <a:solidFill>
-            <a:srgbClr val="4F46E5"/>
+            <a:srgbClr val="FFFFFF"/>
           </a:solidFill>
-          <a:ln w="12700">
+          <a:ln w="25400">
             <a:solidFill>
               <a:srgbClr val="4F46E5"/>
             </a:solidFill>
@@ -5939,17 +6579,17 @@
               <a:buNone/>
             </a:pPr>
             <a:r>
-              <a:rPr lang="en-US" sz="2000" b="1" dirty="0">
+              <a:rPr lang="en-US" sz="1900" b="1" dirty="0">
                 <a:solidFill>
                   <a:srgbClr val="FFFFFF"/>
                 </a:solidFill>
-                <a:latin typeface="Calibri" pitchFamily="34" charset="0"/>
-                <a:ea typeface="Calibri" pitchFamily="34" charset="-122"/>
-                <a:cs typeface="Calibri" pitchFamily="34" charset="-120"/>
-              </a:rPr>
-              <a:t>1</a:t>
-            </a:r>
-            <a:endParaRPr lang="en-US" sz="2000" dirty="0"/>
+                <a:latin typeface="Segoe UI Emoji" pitchFamily="34" charset="0"/>
+                <a:ea typeface="Segoe UI Emoji" pitchFamily="34" charset="-122"/>
+                <a:cs typeface="Segoe UI Emoji" pitchFamily="34" charset="-120"/>
+              </a:rPr>
+              <a:t>✅</a:t>
+            </a:r>
+            <a:endParaRPr lang="en-US" sz="1900" dirty="0"/>
           </a:p>
         </p:txBody>
       </p:sp>
@@ -6119,9 +6759,9 @@
             <a:avLst/>
           </a:prstGeom>
           <a:solidFill>
-            <a:srgbClr val="4F46E5"/>
+            <a:srgbClr val="FFFFFF"/>
           </a:solidFill>
-          <a:ln w="12700">
+          <a:ln w="25400">
             <a:solidFill>
               <a:srgbClr val="4F46E5"/>
             </a:solidFill>
@@ -6154,17 +6794,17 @@
               <a:buNone/>
             </a:pPr>
             <a:r>
-              <a:rPr lang="en-US" sz="2000" b="1" dirty="0">
+              <a:rPr lang="en-US" sz="1900" b="1" dirty="0">
                 <a:solidFill>
                   <a:srgbClr val="FFFFFF"/>
                 </a:solidFill>
-                <a:latin typeface="Calibri" pitchFamily="34" charset="0"/>
-                <a:ea typeface="Calibri" pitchFamily="34" charset="-122"/>
-                <a:cs typeface="Calibri" pitchFamily="34" charset="-120"/>
-              </a:rPr>
-              <a:t>2</a:t>
-            </a:r>
-            <a:endParaRPr lang="en-US" sz="2000" dirty="0"/>
+                <a:latin typeface="Segoe UI Emoji" pitchFamily="34" charset="0"/>
+                <a:ea typeface="Segoe UI Emoji" pitchFamily="34" charset="-122"/>
+                <a:cs typeface="Segoe UI Emoji" pitchFamily="34" charset="-120"/>
+              </a:rPr>
+              <a:t>❌</a:t>
+            </a:r>
+            <a:endParaRPr lang="en-US" sz="1900" dirty="0"/>
           </a:p>
         </p:txBody>
       </p:sp>
@@ -6334,9 +6974,9 @@
             <a:avLst/>
           </a:prstGeom>
           <a:solidFill>
-            <a:srgbClr val="4F46E5"/>
+            <a:srgbClr val="FFFFFF"/>
           </a:solidFill>
-          <a:ln w="12700">
+          <a:ln w="25400">
             <a:solidFill>
               <a:srgbClr val="4F46E5"/>
             </a:solidFill>
@@ -6369,17 +7009,17 @@
               <a:buNone/>
             </a:pPr>
             <a:r>
-              <a:rPr lang="en-US" sz="2000" b="1" dirty="0">
+              <a:rPr lang="en-US" sz="1900" b="1" dirty="0">
                 <a:solidFill>
                   <a:srgbClr val="FFFFFF"/>
                 </a:solidFill>
-                <a:latin typeface="Calibri" pitchFamily="34" charset="0"/>
-                <a:ea typeface="Calibri" pitchFamily="34" charset="-122"/>
-                <a:cs typeface="Calibri" pitchFamily="34" charset="-120"/>
-              </a:rPr>
-              <a:t>3</a:t>
-            </a:r>
-            <a:endParaRPr lang="en-US" sz="2000" dirty="0"/>
+                <a:latin typeface="Segoe UI Emoji" pitchFamily="34" charset="0"/>
+                <a:ea typeface="Segoe UI Emoji" pitchFamily="34" charset="-122"/>
+                <a:cs typeface="Segoe UI Emoji" pitchFamily="34" charset="-120"/>
+              </a:rPr>
+              <a:t>❓</a:t>
+            </a:r>
+            <a:endParaRPr lang="en-US" sz="1900" dirty="0"/>
           </a:p>
         </p:txBody>
       </p:sp>
@@ -6549,9 +7189,9 @@
             <a:avLst/>
           </a:prstGeom>
           <a:solidFill>
-            <a:srgbClr val="4F46E5"/>
+            <a:srgbClr val="FFFFFF"/>
           </a:solidFill>
-          <a:ln w="12700">
+          <a:ln w="25400">
             <a:solidFill>
               <a:srgbClr val="4F46E5"/>
             </a:solidFill>
@@ -6584,17 +7224,17 @@
               <a:buNone/>
             </a:pPr>
             <a:r>
-              <a:rPr lang="en-US" sz="2000" b="1" dirty="0">
+              <a:rPr lang="en-US" sz="1900" b="1" dirty="0">
                 <a:solidFill>
                   <a:srgbClr val="FFFFFF"/>
                 </a:solidFill>
-                <a:latin typeface="Calibri" pitchFamily="34" charset="0"/>
-                <a:ea typeface="Calibri" pitchFamily="34" charset="-122"/>
-                <a:cs typeface="Calibri" pitchFamily="34" charset="-120"/>
-              </a:rPr>
-              <a:t>4</a:t>
-            </a:r>
-            <a:endParaRPr lang="en-US" sz="2000" dirty="0"/>
+                <a:latin typeface="Segoe UI Emoji" pitchFamily="34" charset="0"/>
+                <a:ea typeface="Segoe UI Emoji" pitchFamily="34" charset="-122"/>
+                <a:cs typeface="Segoe UI Emoji" pitchFamily="34" charset="-120"/>
+              </a:rPr>
+              <a:t>📍</a:t>
+            </a:r>
+            <a:endParaRPr lang="en-US" sz="1900" dirty="0"/>
           </a:p>
         </p:txBody>
       </p:sp>
@@ -6908,11 +7548,25 @@
                 <a:solidFill>
                   <a:srgbClr val="1B1F3B"/>
                 </a:solidFill>
+                <a:latin typeface="Segoe UI Emoji" pitchFamily="34" charset="0"/>
+                <a:ea typeface="Segoe UI Emoji" pitchFamily="34" charset="-122"/>
+                <a:cs typeface="Segoe UI Emoji" pitchFamily="34" charset="-120"/>
+              </a:rPr>
+              <a:t>✏️</a:t>
+            </a:r>
+            <a:pPr indent="0" marL="0">
+              <a:buNone/>
+            </a:pPr>
+            <a:r>
+              <a:rPr lang="en-US" sz="2800" b="1" dirty="0">
+                <a:solidFill>
+                  <a:srgbClr val="1B1F3B"/>
+                </a:solidFill>
                 <a:latin typeface="Cambria" pitchFamily="34" charset="0"/>
                 <a:ea typeface="Cambria" pitchFamily="34" charset="-122"/>
                 <a:cs typeface="Cambria" pitchFamily="34" charset="-120"/>
               </a:rPr>
-              <a:t>1-misol: tasdiq gap</a:t>
+              <a:t> 1-misol: tasdiq gap</a:t>
             </a:r>
             <a:endParaRPr lang="en-US" sz="2800" dirty="0"/>
           </a:p>
@@ -6974,11 +7628,25 @@
                 <a:solidFill>
                   <a:srgbClr val="F59E0B"/>
                 </a:solidFill>
+                <a:latin typeface="Segoe UI Emoji" pitchFamily="34" charset="0"/>
+                <a:ea typeface="Segoe UI Emoji" pitchFamily="34" charset="-122"/>
+                <a:cs typeface="Segoe UI Emoji" pitchFamily="34" charset="-120"/>
+              </a:rPr>
+              <a:t>📝</a:t>
+            </a:r>
+            <a:pPr indent="0" marL="0">
+              <a:buNone/>
+            </a:pPr>
+            <a:r>
+              <a:rPr lang="en-US" sz="900" b="1" spc="100" kern="0" dirty="0">
+                <a:solidFill>
+                  <a:srgbClr val="F59E0B"/>
+                </a:solidFill>
                 <a:latin typeface="Calibri" pitchFamily="34" charset="0"/>
                 <a:ea typeface="Calibri" pitchFamily="34" charset="-122"/>
                 <a:cs typeface="Calibri" pitchFamily="34" charset="-120"/>
               </a:rPr>
-              <a:t>TOPSHIRIQ</a:t>
+              <a:t> TOPSHIRIQ</a:t>
             </a:r>
             <a:endParaRPr lang="en-US" sz="900" dirty="0"/>
           </a:p>
@@ -7075,6 +7743,20 @@
               <a:buNone/>
             </a:pPr>
             <a:r>
+              <a:rPr lang="en-US" sz="800" dirty="0">
+                <a:solidFill>
+                  <a:srgbClr val="F59E0B"/>
+                </a:solidFill>
+                <a:latin typeface="Segoe UI Emoji" pitchFamily="34" charset="0"/>
+                <a:ea typeface="Segoe UI Emoji" pitchFamily="34" charset="-122"/>
+                <a:cs typeface="Segoe UI Emoji" pitchFamily="34" charset="-120"/>
+              </a:rPr>
+              <a:t>💡</a:t>
+            </a:r>
+            <a:pPr indent="0" marL="0">
+              <a:buNone/>
+            </a:pPr>
+            <a:r>
               <a:rPr lang="en-US" sz="800" b="1" dirty="0">
                 <a:solidFill>
                   <a:srgbClr val="F59E0B"/>
@@ -7083,7 +7765,7 @@
                 <a:ea typeface="Calibri" pitchFamily="34" charset="-122"/>
                 <a:cs typeface="Calibri" pitchFamily="34" charset="-120"/>
               </a:rPr>
-              <a:t>STRATEGIYA</a:t>
+              <a:t> STRATEGIYA</a:t>
             </a:r>
             <a:endParaRPr lang="en-US" sz="800" dirty="0"/>
           </a:p>
@@ -7725,11 +8407,25 @@
                 <a:solidFill>
                   <a:srgbClr val="065F46"/>
                 </a:solidFill>
+                <a:latin typeface="Segoe UI Emoji" pitchFamily="34" charset="0"/>
+                <a:ea typeface="Segoe UI Emoji" pitchFamily="34" charset="-122"/>
+                <a:cs typeface="Segoe UI Emoji" pitchFamily="34" charset="-120"/>
+              </a:rPr>
+              <a:t>✅</a:t>
+            </a:r>
+            <a:pPr indent="0" marL="0">
+              <a:buNone/>
+            </a:pPr>
+            <a:r>
+              <a:rPr lang="en-US" sz="1000" dirty="0">
+                <a:solidFill>
+                  <a:srgbClr val="065F46"/>
+                </a:solidFill>
                 <a:latin typeface="Calibri" pitchFamily="34" charset="0"/>
                 <a:ea typeface="Calibri" pitchFamily="34" charset="-122"/>
                 <a:cs typeface="Calibri" pitchFamily="34" charset="-120"/>
               </a:rPr>
-              <a:t>Tekshiruv: «every Saturday» — takrorlanadigan odat, demak Present Simple ✓</a:t>
+              <a:t> Tekshiruv: «every Saturday» — takrorlanadigan odat, demak Present Simple ✓</a:t>
             </a:r>
             <a:endParaRPr lang="en-US" sz="1000" dirty="0"/>
           </a:p>
@@ -7837,11 +8533,25 @@
                 <a:solidFill>
                   <a:srgbClr val="1B1F3B"/>
                 </a:solidFill>
+                <a:latin typeface="Segoe UI Emoji" pitchFamily="34" charset="0"/>
+                <a:ea typeface="Segoe UI Emoji" pitchFamily="34" charset="-122"/>
+                <a:cs typeface="Segoe UI Emoji" pitchFamily="34" charset="-120"/>
+              </a:rPr>
+              <a:t>💬</a:t>
+            </a:r>
+            <a:pPr indent="0" marL="0">
+              <a:buNone/>
+            </a:pPr>
+            <a:r>
+              <a:rPr lang="en-US" sz="2800" b="1" dirty="0">
+                <a:solidFill>
+                  <a:srgbClr val="1B1F3B"/>
+                </a:solidFill>
                 <a:latin typeface="Cambria" pitchFamily="34" charset="0"/>
                 <a:ea typeface="Cambria" pitchFamily="34" charset="-122"/>
                 <a:cs typeface="Cambria" pitchFamily="34" charset="-120"/>
               </a:rPr>
-              <a:t>2-misol: so'roq va qisqa javob</a:t>
+              <a:t> 2-misol: so'roq va qisqa javob</a:t>
             </a:r>
             <a:endParaRPr lang="en-US" sz="2800" dirty="0"/>
           </a:p>
@@ -7903,11 +8613,25 @@
                 <a:solidFill>
                   <a:srgbClr val="F59E0B"/>
                 </a:solidFill>
+                <a:latin typeface="Segoe UI Emoji" pitchFamily="34" charset="0"/>
+                <a:ea typeface="Segoe UI Emoji" pitchFamily="34" charset="-122"/>
+                <a:cs typeface="Segoe UI Emoji" pitchFamily="34" charset="-120"/>
+              </a:rPr>
+              <a:t>📝</a:t>
+            </a:r>
+            <a:pPr indent="0" marL="0">
+              <a:buNone/>
+            </a:pPr>
+            <a:r>
+              <a:rPr lang="en-US" sz="900" b="1" spc="100" kern="0" dirty="0">
+                <a:solidFill>
+                  <a:srgbClr val="F59E0B"/>
+                </a:solidFill>
                 <a:latin typeface="Calibri" pitchFamily="34" charset="0"/>
                 <a:ea typeface="Calibri" pitchFamily="34" charset="-122"/>
                 <a:cs typeface="Calibri" pitchFamily="34" charset="-120"/>
               </a:rPr>
-              <a:t>TOPSHIRIQ</a:t>
+              <a:t> TOPSHIRIQ</a:t>
             </a:r>
             <a:endParaRPr lang="en-US" sz="900" dirty="0"/>
           </a:p>
@@ -8032,6 +8756,20 @@
               <a:buNone/>
             </a:pPr>
             <a:r>
+              <a:rPr lang="en-US" sz="800" dirty="0">
+                <a:solidFill>
+                  <a:srgbClr val="F59E0B"/>
+                </a:solidFill>
+                <a:latin typeface="Segoe UI Emoji" pitchFamily="34" charset="0"/>
+                <a:ea typeface="Segoe UI Emoji" pitchFamily="34" charset="-122"/>
+                <a:cs typeface="Segoe UI Emoji" pitchFamily="34" charset="-120"/>
+              </a:rPr>
+              <a:t>💡</a:t>
+            </a:r>
+            <a:pPr indent="0" marL="0">
+              <a:buNone/>
+            </a:pPr>
+            <a:r>
               <a:rPr lang="en-US" sz="800" b="1" dirty="0">
                 <a:solidFill>
                   <a:srgbClr val="F59E0B"/>
@@ -8040,7 +8778,7 @@
                 <a:ea typeface="Calibri" pitchFamily="34" charset="-122"/>
                 <a:cs typeface="Calibri" pitchFamily="34" charset="-120"/>
               </a:rPr>
-              <a:t>STRATEGIYA</a:t>
+              <a:t> STRATEGIYA</a:t>
             </a:r>
             <a:endParaRPr lang="en-US" sz="800" dirty="0"/>
           </a:p>
@@ -8949,11 +9687,25 @@
                 <a:solidFill>
                   <a:srgbClr val="065F46"/>
                 </a:solidFill>
+                <a:latin typeface="Segoe UI Emoji" pitchFamily="34" charset="0"/>
+                <a:ea typeface="Segoe UI Emoji" pitchFamily="34" charset="-122"/>
+                <a:cs typeface="Segoe UI Emoji" pitchFamily="34" charset="-120"/>
+              </a:rPr>
+              <a:t>✅</a:t>
+            </a:r>
+            <a:pPr indent="0" marL="0">
+              <a:buNone/>
+            </a:pPr>
+            <a:r>
+              <a:rPr lang="en-US" sz="1100" dirty="0">
+                <a:solidFill>
+                  <a:srgbClr val="065F46"/>
+                </a:solidFill>
                 <a:latin typeface="Calibri" pitchFamily="34" charset="0"/>
                 <a:ea typeface="Calibri" pitchFamily="34" charset="-122"/>
                 <a:cs typeface="Calibri" pitchFamily="34" charset="-120"/>
               </a:rPr>
-              <a:t>Qisqa javobda asosiy fe'l takrorlanmaydi: Yes, she works ✗.</a:t>
+              <a:t> Qisqa javobda asosiy fe'l takrorlanmaydi: Yes, she works ✗.</a:t>
             </a:r>
             <a:endParaRPr lang="en-US" sz="1100" dirty="0"/>
           </a:p>
@@ -9061,11 +9813,25 @@
                 <a:solidFill>
                   <a:srgbClr val="1B1F3B"/>
                 </a:solidFill>
+                <a:latin typeface="Segoe UI Emoji" pitchFamily="34" charset="0"/>
+                <a:ea typeface="Segoe UI Emoji" pitchFamily="34" charset="-122"/>
+                <a:cs typeface="Segoe UI Emoji" pitchFamily="34" charset="-120"/>
+              </a:rPr>
+              <a:t>🧩</a:t>
+            </a:r>
+            <a:pPr indent="0" marL="0">
+              <a:buNone/>
+            </a:pPr>
+            <a:r>
+              <a:rPr lang="en-US" sz="2800" b="1" dirty="0">
+                <a:solidFill>
+                  <a:srgbClr val="1B1F3B"/>
+                </a:solidFill>
                 <a:latin typeface="Cambria" pitchFamily="34" charset="0"/>
                 <a:ea typeface="Cambria" pitchFamily="34" charset="-122"/>
                 <a:cs typeface="Cambria" pitchFamily="34" charset="-120"/>
               </a:rPr>
-              <a:t>3-shaxs: -s, -es yoki -ies?</a:t>
+              <a:t> 3-shaxs: -s, -es yoki -ies?</a:t>
             </a:r>
             <a:endParaRPr lang="en-US" sz="2800" dirty="0"/>
           </a:p>
@@ -10121,11 +10887,25 @@
                 <a:solidFill>
                   <a:srgbClr val="1B1F3B"/>
                 </a:solidFill>
+                <a:latin typeface="Segoe UI Emoji" pitchFamily="34" charset="0"/>
+                <a:ea typeface="Segoe UI Emoji" pitchFamily="34" charset="-122"/>
+                <a:cs typeface="Segoe UI Emoji" pitchFamily="34" charset="-120"/>
+              </a:rPr>
+              <a:t>📍</a:t>
+            </a:r>
+            <a:pPr indent="0" marL="0">
+              <a:buNone/>
+            </a:pPr>
+            <a:r>
+              <a:rPr lang="en-US" sz="2800" b="1" dirty="0">
+                <a:solidFill>
+                  <a:srgbClr val="1B1F3B"/>
+                </a:solidFill>
                 <a:latin typeface="Cambria" pitchFamily="34" charset="0"/>
                 <a:ea typeface="Cambria" pitchFamily="34" charset="-122"/>
                 <a:cs typeface="Cambria" pitchFamily="34" charset="-120"/>
               </a:rPr>
-              <a:t>3-misol: chastota ravishi</a:t>
+              <a:t> 3-misol: chastota ravishi</a:t>
             </a:r>
             <a:endParaRPr lang="en-US" sz="2800" dirty="0"/>
           </a:p>
@@ -10187,11 +10967,25 @@
                 <a:solidFill>
                   <a:srgbClr val="F59E0B"/>
                 </a:solidFill>
+                <a:latin typeface="Segoe UI Emoji" pitchFamily="34" charset="0"/>
+                <a:ea typeface="Segoe UI Emoji" pitchFamily="34" charset="-122"/>
+                <a:cs typeface="Segoe UI Emoji" pitchFamily="34" charset="-120"/>
+              </a:rPr>
+              <a:t>📝</a:t>
+            </a:r>
+            <a:pPr indent="0" marL="0">
+              <a:buNone/>
+            </a:pPr>
+            <a:r>
+              <a:rPr lang="en-US" sz="900" b="1" spc="100" kern="0" dirty="0">
+                <a:solidFill>
+                  <a:srgbClr val="F59E0B"/>
+                </a:solidFill>
                 <a:latin typeface="Calibri" pitchFamily="34" charset="0"/>
                 <a:ea typeface="Calibri" pitchFamily="34" charset="-122"/>
                 <a:cs typeface="Calibri" pitchFamily="34" charset="-120"/>
               </a:rPr>
-              <a:t>TOPSHIRIQ</a:t>
+              <a:t> TOPSHIRIQ</a:t>
             </a:r>
             <a:endParaRPr lang="en-US" sz="900" dirty="0"/>
           </a:p>
@@ -10316,6 +11110,20 @@
               <a:buNone/>
             </a:pPr>
             <a:r>
+              <a:rPr lang="en-US" sz="800" dirty="0">
+                <a:solidFill>
+                  <a:srgbClr val="F59E0B"/>
+                </a:solidFill>
+                <a:latin typeface="Segoe UI Emoji" pitchFamily="34" charset="0"/>
+                <a:ea typeface="Segoe UI Emoji" pitchFamily="34" charset="-122"/>
+                <a:cs typeface="Segoe UI Emoji" pitchFamily="34" charset="-120"/>
+              </a:rPr>
+              <a:t>💡</a:t>
+            </a:r>
+            <a:pPr indent="0" marL="0">
+              <a:buNone/>
+            </a:pPr>
+            <a:r>
               <a:rPr lang="en-US" sz="800" b="1" dirty="0">
                 <a:solidFill>
                   <a:srgbClr val="F59E0B"/>
@@ -10324,7 +11132,7 @@
                 <a:ea typeface="Calibri" pitchFamily="34" charset="-122"/>
                 <a:cs typeface="Calibri" pitchFamily="34" charset="-120"/>
               </a:rPr>
-              <a:t>STRATEGIYA</a:t>
+              <a:t> STRATEGIYA</a:t>
             </a:r>
             <a:endParaRPr lang="en-US" sz="800" dirty="0"/>
           </a:p>
@@ -11152,11 +11960,25 @@
                 <a:solidFill>
                   <a:srgbClr val="065F46"/>
                 </a:solidFill>
+                <a:latin typeface="Segoe UI Emoji" pitchFamily="34" charset="0"/>
+                <a:ea typeface="Segoe UI Emoji" pitchFamily="34" charset="-122"/>
+                <a:cs typeface="Segoe UI Emoji" pitchFamily="34" charset="-120"/>
+              </a:rPr>
+              <a:t>✅</a:t>
+            </a:r>
+            <a:pPr indent="0" marL="0">
+              <a:buNone/>
+            </a:pPr>
+            <a:r>
+              <a:rPr lang="en-US" sz="1000" dirty="0">
+                <a:solidFill>
+                  <a:srgbClr val="065F46"/>
+                </a:solidFill>
                 <a:latin typeface="Calibri" pitchFamily="34" charset="0"/>
                 <a:ea typeface="Calibri" pitchFamily="34" charset="-122"/>
                 <a:cs typeface="Calibri" pitchFamily="34" charset="-120"/>
               </a:rPr>
-              <a:t>Eslatma: sometimes va usually gap boshida ham kelishi mumkin: Sometimes I walk to school.</a:t>
+              <a:t> Eslatma: sometimes va usually gap boshida ham kelishi mumkin: Sometimes I walk to school.</a:t>
             </a:r>
             <a:endParaRPr lang="en-US" sz="1000" dirty="0"/>
           </a:p>
@@ -11264,11 +12086,25 @@
                 <a:solidFill>
                   <a:srgbClr val="1B1F3B"/>
                 </a:solidFill>
+                <a:latin typeface="Segoe UI Emoji" pitchFamily="34" charset="0"/>
+                <a:ea typeface="Segoe UI Emoji" pitchFamily="34" charset="-122"/>
+                <a:cs typeface="Segoe UI Emoji" pitchFamily="34" charset="-120"/>
+              </a:rPr>
+              <a:t>🧠</a:t>
+            </a:r>
+            <a:pPr indent="0" marL="0">
+              <a:buNone/>
+            </a:pPr>
+            <a:r>
+              <a:rPr lang="en-US" sz="2800" b="1" dirty="0">
+                <a:solidFill>
+                  <a:srgbClr val="1B1F3B"/>
+                </a:solidFill>
                 <a:latin typeface="Cambria" pitchFamily="34" charset="0"/>
                 <a:ea typeface="Cambria" pitchFamily="34" charset="-122"/>
                 <a:cs typeface="Cambria" pitchFamily="34" charset="-120"/>
               </a:rPr>
-              <a:t>Tuzoq va talaffuz</a:t>
+              <a:t> Tuzoq va talaffuz</a:t>
             </a:r>
             <a:endParaRPr lang="en-US" sz="2800" dirty="0"/>
           </a:p>
@@ -11316,9 +12152,9 @@
             <a:avLst/>
           </a:prstGeom>
           <a:solidFill>
-            <a:srgbClr val="F59E0B"/>
+            <a:srgbClr val="FFFFFF"/>
           </a:solidFill>
-          <a:ln w="12700">
+          <a:ln w="25400">
             <a:solidFill>
               <a:srgbClr val="F59E0B"/>
             </a:solidFill>
@@ -11351,17 +12187,17 @@
               <a:buNone/>
             </a:pPr>
             <a:r>
-              <a:rPr lang="en-US" sz="1800" b="1" dirty="0">
+              <a:rPr lang="en-US" sz="1900" b="1" dirty="0">
                 <a:solidFill>
                   <a:srgbClr val="FFFFFF"/>
                 </a:solidFill>
-                <a:latin typeface="Calibri" pitchFamily="34" charset="0"/>
-                <a:ea typeface="Calibri" pitchFamily="34" charset="-122"/>
-                <a:cs typeface="Calibri" pitchFamily="34" charset="-120"/>
-              </a:rPr>
-              <a:t>!</a:t>
-            </a:r>
-            <a:endParaRPr lang="en-US" sz="1800" dirty="0"/>
+                <a:latin typeface="Segoe UI Emoji" pitchFamily="34" charset="0"/>
+                <a:ea typeface="Segoe UI Emoji" pitchFamily="34" charset="-122"/>
+                <a:cs typeface="Segoe UI Emoji" pitchFamily="34" charset="-120"/>
+              </a:rPr>
+              <a:t>⚠️</a:t>
+            </a:r>
+            <a:endParaRPr lang="en-US" sz="1900" dirty="0"/>
           </a:p>
         </p:txBody>
       </p:sp>
@@ -11524,9 +12360,9 @@
             <a:avLst/>
           </a:prstGeom>
           <a:solidFill>
-            <a:srgbClr val="4F46E5"/>
+            <a:srgbClr val="FFFFFF"/>
           </a:solidFill>
-          <a:ln w="12700">
+          <a:ln w="25400">
             <a:solidFill>
               <a:srgbClr val="4F46E5"/>
             </a:solidFill>
@@ -11559,17 +12395,17 @@
               <a:buNone/>
             </a:pPr>
             <a:r>
-              <a:rPr lang="en-US" sz="1200" b="1" dirty="0">
+              <a:rPr lang="en-US" sz="1900" b="1" dirty="0">
                 <a:solidFill>
                   <a:srgbClr val="FFFFFF"/>
                 </a:solidFill>
-                <a:latin typeface="Calibri" pitchFamily="34" charset="0"/>
-                <a:ea typeface="Calibri" pitchFamily="34" charset="-122"/>
-                <a:cs typeface="Calibri" pitchFamily="34" charset="-120"/>
-              </a:rPr>
-              <a:t>/s/</a:t>
-            </a:r>
-            <a:endParaRPr lang="en-US" sz="1200" dirty="0"/>
+                <a:latin typeface="Segoe UI Emoji" pitchFamily="34" charset="0"/>
+                <a:ea typeface="Segoe UI Emoji" pitchFamily="34" charset="-122"/>
+                <a:cs typeface="Segoe UI Emoji" pitchFamily="34" charset="-120"/>
+              </a:rPr>
+              <a:t>🔊</a:t>
+            </a:r>
+            <a:endParaRPr lang="en-US" sz="1900" dirty="0"/>
           </a:p>
         </p:txBody>
       </p:sp>

</xml_diff>